<commit_message>
Rebuild heat map as area-proportional treemap
Tile area is now linear with volume so Documentation dominates and
Support reads as one of the smallest surfaces. Discord stays an
off-scale TBD rail. Support remains the only bold label.

Co-authored-by: Barnir <assafbar2@users.noreply.github.com>
</commit_message>
<xml_diff>
--- a/submission/support-heatmap/support-channel-heatmap.pptx
+++ b/submission/support-heatmap/support-channel-heatmap.pptx
@@ -3139,8 +3139,8 @@
         </p:nvSpPr>
         <p:spPr>
           <a:xfrm>
-            <a:off x="548640" y="320040"/>
-            <a:ext cx="11064240" cy="411480"/>
+            <a:off x="502920" y="256032"/>
+            <a:ext cx="11155680" cy="365760"/>
           </a:xfrm>
           <a:prstGeom prst="rect">
             <a:avLst/>
@@ -3173,8 +3173,8 @@
         </p:nvSpPr>
         <p:spPr>
           <a:xfrm>
-            <a:off x="548640" y="713232"/>
-            <a:ext cx="11064240" cy="320040"/>
+            <a:off x="502920" y="621792"/>
+            <a:ext cx="11155680" cy="292608"/>
           </a:xfrm>
           <a:prstGeom prst="rect">
             <a:avLst/>
@@ -3194,7 +3194,7 @@
                 </a:solidFill>
                 <a:latin typeface="Calibri"/>
               </a:rPr>
-              <a:t>Heat = relative volume across support-adjacent surfaces. Same type everywhere — Support is bold.</a:t>
+              <a:t>Tile size = volume (linear). Color reinforces the same scale. Same type everywhere — Support is bold.</a:t>
             </a:r>
           </a:p>
         </p:txBody>
@@ -3207,12 +3207,12 @@
         </p:nvSpPr>
         <p:spPr>
           <a:xfrm>
-            <a:off x="548640" y="1234440"/>
-            <a:ext cx="2677591" cy="1833372"/>
+            <a:off x="508406" y="1057046"/>
+            <a:ext cx="6699570" cy="4423868"/>
           </a:xfrm>
           <a:prstGeom prst="roundRect">
             <a:avLst>
-              <a:gd name="adj" fmla="val 8000"/>
+              <a:gd name="adj" fmla="val 5000"/>
             </a:avLst>
           </a:prstGeom>
           <a:solidFill>
@@ -3242,11 +3242,11 @@
           <a:p>
             <a:pPr algn="ctr">
               <a:spcAft>
-                <a:spcPts val="400"/>
+                <a:spcPts val="200"/>
               </a:spcAft>
             </a:pPr>
             <a:r>
-              <a:rPr sz="1400" b="0">
+              <a:rPr sz="1200" b="0">
                 <a:solidFill>
                   <a:srgbClr val="FFFBF6"/>
                 </a:solidFill>
@@ -3258,7 +3258,7 @@
           <a:p>
             <a:pPr algn="ctr"/>
             <a:r>
-              <a:rPr sz="1800" b="0">
+              <a:rPr sz="1500" b="0">
                 <a:solidFill>
                   <a:srgbClr val="FFFBF6"/>
                 </a:solidFill>
@@ -3277,12 +3277,12 @@
         </p:nvSpPr>
         <p:spPr>
           <a:xfrm>
-            <a:off x="3354247" y="1234440"/>
-            <a:ext cx="2677591" cy="1833372"/>
+            <a:off x="7218948" y="1057046"/>
+            <a:ext cx="3764826" cy="3982486"/>
           </a:xfrm>
           <a:prstGeom prst="roundRect">
             <a:avLst>
-              <a:gd name="adj" fmla="val 8000"/>
+              <a:gd name="adj" fmla="val 5000"/>
             </a:avLst>
           </a:prstGeom>
           <a:solidFill>
@@ -3312,11 +3312,11 @@
           <a:p>
             <a:pPr algn="ctr">
               <a:spcAft>
-                <a:spcPts val="400"/>
+                <a:spcPts val="200"/>
               </a:spcAft>
             </a:pPr>
             <a:r>
-              <a:rPr sz="1400" b="0">
+              <a:rPr sz="1200" b="0">
                 <a:solidFill>
                   <a:srgbClr val="FFFBF6"/>
                 </a:solidFill>
@@ -3328,7 +3328,7 @@
           <a:p>
             <a:pPr algn="ctr"/>
             <a:r>
-              <a:rPr sz="1800" b="0">
+              <a:rPr sz="1500" b="0">
                 <a:solidFill>
                   <a:srgbClr val="FFFBF6"/>
                 </a:solidFill>
@@ -3347,12 +3347,12 @@
         </p:nvSpPr>
         <p:spPr>
           <a:xfrm>
-            <a:off x="6159854" y="1234440"/>
-            <a:ext cx="2677591" cy="1833372"/>
+            <a:off x="7218948" y="5050504"/>
+            <a:ext cx="2461277" cy="430410"/>
           </a:xfrm>
           <a:prstGeom prst="roundRect">
             <a:avLst>
-              <a:gd name="adj" fmla="val 8000"/>
+              <a:gd name="adj" fmla="val 5000"/>
             </a:avLst>
           </a:prstGeom>
           <a:solidFill>
@@ -3382,11 +3382,11 @@
           <a:p>
             <a:pPr algn="ctr">
               <a:spcAft>
-                <a:spcPts val="400"/>
+                <a:spcPts val="200"/>
               </a:spcAft>
             </a:pPr>
             <a:r>
-              <a:rPr sz="1400" b="0">
+              <a:rPr sz="1200" b="0">
                 <a:solidFill>
                   <a:srgbClr val="1A1714"/>
                 </a:solidFill>
@@ -3398,7 +3398,7 @@
           <a:p>
             <a:pPr algn="ctr"/>
             <a:r>
-              <a:rPr sz="1800" b="0">
+              <a:rPr sz="1500" b="0">
                 <a:solidFill>
                   <a:srgbClr val="1A1714"/>
                 </a:solidFill>
@@ -3417,12 +3417,12 @@
         </p:nvSpPr>
         <p:spPr>
           <a:xfrm>
-            <a:off x="8965461" y="1234440"/>
-            <a:ext cx="2677591" cy="1833372"/>
+            <a:off x="9691197" y="5050504"/>
+            <a:ext cx="550903" cy="430410"/>
           </a:xfrm>
           <a:prstGeom prst="roundRect">
             <a:avLst>
-              <a:gd name="adj" fmla="val 8000"/>
+              <a:gd name="adj" fmla="val 5000"/>
             </a:avLst>
           </a:prstGeom>
           <a:solidFill>
@@ -3452,11 +3452,11 @@
           <a:p>
             <a:pPr algn="ctr">
               <a:spcAft>
-                <a:spcPts val="400"/>
+                <a:spcPts val="200"/>
               </a:spcAft>
             </a:pPr>
             <a:r>
-              <a:rPr sz="1400" b="0">
+              <a:rPr sz="1200" b="0">
                 <a:solidFill>
                   <a:srgbClr val="1A1714"/>
                 </a:solidFill>
@@ -3468,7 +3468,7 @@
           <a:p>
             <a:pPr algn="ctr"/>
             <a:r>
-              <a:rPr sz="1800" b="0">
+              <a:rPr sz="1500" b="0">
                 <a:solidFill>
                   <a:srgbClr val="1A1714"/>
                 </a:solidFill>
@@ -3487,12 +3487,12 @@
         </p:nvSpPr>
         <p:spPr>
           <a:xfrm>
-            <a:off x="548640" y="3195828"/>
-            <a:ext cx="2677591" cy="1833372"/>
+            <a:off x="10253071" y="5050504"/>
+            <a:ext cx="550903" cy="430410"/>
           </a:xfrm>
           <a:prstGeom prst="roundRect">
             <a:avLst>
-              <a:gd name="adj" fmla="val 8000"/>
+              <a:gd name="adj" fmla="val 5000"/>
             </a:avLst>
           </a:prstGeom>
           <a:solidFill>
@@ -3522,11 +3522,11 @@
           <a:p>
             <a:pPr algn="ctr">
               <a:spcAft>
-                <a:spcPts val="400"/>
+                <a:spcPts val="200"/>
               </a:spcAft>
             </a:pPr>
             <a:r>
-              <a:rPr sz="1400" b="1">
+              <a:rPr sz="1200" b="1">
                 <a:solidFill>
                   <a:srgbClr val="1A1714"/>
                 </a:solidFill>
@@ -3538,7 +3538,7 @@
           <a:p>
             <a:pPr algn="ctr"/>
             <a:r>
-              <a:rPr sz="1800" b="0">
+              <a:rPr sz="1500" b="0">
                 <a:solidFill>
                   <a:srgbClr val="1A1714"/>
                 </a:solidFill>
@@ -3557,12 +3557,12 @@
         </p:nvSpPr>
         <p:spPr>
           <a:xfrm>
-            <a:off x="3354247" y="3195828"/>
-            <a:ext cx="2677591" cy="1833372"/>
+            <a:off x="10814946" y="5050504"/>
+            <a:ext cx="123878" cy="430410"/>
           </a:xfrm>
           <a:prstGeom prst="roundRect">
             <a:avLst>
-              <a:gd name="adj" fmla="val 8000"/>
+              <a:gd name="adj" fmla="val 5000"/>
             </a:avLst>
           </a:prstGeom>
           <a:solidFill>
@@ -3592,11 +3592,11 @@
           <a:p>
             <a:pPr algn="ctr">
               <a:spcAft>
-                <a:spcPts val="400"/>
+                <a:spcPts val="200"/>
               </a:spcAft>
             </a:pPr>
             <a:r>
-              <a:rPr sz="1400" b="0">
+              <a:rPr sz="1200" b="0">
                 <a:solidFill>
                   <a:srgbClr val="1A1714"/>
                 </a:solidFill>
@@ -3608,7 +3608,7 @@
           <a:p>
             <a:pPr algn="ctr"/>
             <a:r>
-              <a:rPr sz="1800" b="0">
+              <a:rPr sz="1500" b="0">
                 <a:solidFill>
                   <a:srgbClr val="1A1714"/>
                 </a:solidFill>
@@ -3627,12 +3627,12 @@
         </p:nvSpPr>
         <p:spPr>
           <a:xfrm>
-            <a:off x="6159854" y="3195828"/>
-            <a:ext cx="2677591" cy="1833372"/>
+            <a:off x="10949796" y="5050504"/>
+            <a:ext cx="33978" cy="430410"/>
           </a:xfrm>
           <a:prstGeom prst="roundRect">
             <a:avLst>
-              <a:gd name="adj" fmla="val 8000"/>
+              <a:gd name="adj" fmla="val 5000"/>
             </a:avLst>
           </a:prstGeom>
           <a:solidFill>
@@ -3662,11 +3662,11 @@
           <a:p>
             <a:pPr algn="ctr">
               <a:spcAft>
-                <a:spcPts val="400"/>
+                <a:spcPts val="200"/>
               </a:spcAft>
             </a:pPr>
             <a:r>
-              <a:rPr sz="1400" b="0">
+              <a:rPr sz="1200" b="0">
                 <a:solidFill>
                   <a:srgbClr val="1A1714"/>
                 </a:solidFill>
@@ -3678,7 +3678,7 @@
           <a:p>
             <a:pPr algn="ctr"/>
             <a:r>
-              <a:rPr sz="1800" b="0">
+              <a:rPr sz="1500" b="0">
                 <a:solidFill>
                   <a:srgbClr val="1A1714"/>
                 </a:solidFill>
@@ -3697,12 +3697,12 @@
         </p:nvSpPr>
         <p:spPr>
           <a:xfrm>
-            <a:off x="8965461" y="3195828"/>
-            <a:ext cx="2677591" cy="1833372"/>
+            <a:off x="11005718" y="1057046"/>
+            <a:ext cx="647396" cy="4423868"/>
           </a:xfrm>
           <a:prstGeom prst="roundRect">
             <a:avLst>
-              <a:gd name="adj" fmla="val 8000"/>
+              <a:gd name="adj" fmla="val 5000"/>
             </a:avLst>
           </a:prstGeom>
           <a:solidFill>
@@ -3732,11 +3732,11 @@
           <a:p>
             <a:pPr algn="ctr">
               <a:spcAft>
-                <a:spcPts val="400"/>
+                <a:spcPts val="200"/>
               </a:spcAft>
             </a:pPr>
             <a:r>
-              <a:rPr sz="1400" b="0">
+              <a:rPr sz="1200" b="0">
                 <a:solidFill>
                   <a:srgbClr val="1A1714"/>
                 </a:solidFill>
@@ -3748,7 +3748,7 @@
           <a:p>
             <a:pPr algn="ctr"/>
             <a:r>
-              <a:rPr sz="1800" b="0">
+              <a:rPr sz="1500" b="0">
                 <a:solidFill>
                   <a:srgbClr val="1A1714"/>
                 </a:solidFill>
@@ -3761,1046 +3761,14 @@
       </p:sp>
       <p:sp>
         <p:nvSpPr>
-          <p:cNvPr id="13" name="Rectangle 12"/>
-          <p:cNvSpPr/>
+          <p:cNvPr id="13" name="TextBox 12"/>
+          <p:cNvSpPr txBox="1"/>
           <p:nvPr/>
         </p:nvSpPr>
         <p:spPr>
           <a:xfrm>
-            <a:off x="548640" y="5257800"/>
-            <a:ext cx="162020" cy="201168"/>
-          </a:xfrm>
-          <a:prstGeom prst="rect">
-            <a:avLst/>
-          </a:prstGeom>
-          <a:solidFill>
-            <a:srgbClr val="F0E6D8"/>
-          </a:solidFill>
-          <a:ln>
-            <a:noFill/>
-          </a:ln>
-        </p:spPr>
-        <p:style>
-          <a:lnRef idx="1">
-            <a:schemeClr val="accent1"/>
-          </a:lnRef>
-          <a:fillRef idx="3">
-            <a:schemeClr val="accent1"/>
-          </a:fillRef>
-          <a:effectRef idx="2">
-            <a:schemeClr val="accent1"/>
-          </a:effectRef>
-          <a:fontRef idx="minor">
-            <a:schemeClr val="lt1"/>
-          </a:fontRef>
-        </p:style>
-        <p:txBody>
-          <a:bodyPr rtlCol="0" anchor="ctr"/>
-          <a:lstStyle/>
-          <a:p>
-            <a:pPr algn="ctr"/>
-          </a:p>
-        </p:txBody>
-      </p:sp>
-      <p:sp>
-        <p:nvSpPr>
-          <p:cNvPr id="14" name="Rectangle 13"/>
-          <p:cNvSpPr/>
-          <p:nvPr/>
-        </p:nvSpPr>
-        <p:spPr>
-          <a:xfrm>
-            <a:off x="708660" y="5257800"/>
-            <a:ext cx="162020" cy="201168"/>
-          </a:xfrm>
-          <a:prstGeom prst="rect">
-            <a:avLst/>
-          </a:prstGeom>
-          <a:solidFill>
-            <a:srgbClr val="F0E1CC"/>
-          </a:solidFill>
-          <a:ln>
-            <a:noFill/>
-          </a:ln>
-        </p:spPr>
-        <p:style>
-          <a:lnRef idx="1">
-            <a:schemeClr val="accent1"/>
-          </a:lnRef>
-          <a:fillRef idx="3">
-            <a:schemeClr val="accent1"/>
-          </a:fillRef>
-          <a:effectRef idx="2">
-            <a:schemeClr val="accent1"/>
-          </a:effectRef>
-          <a:fontRef idx="minor">
-            <a:schemeClr val="lt1"/>
-          </a:fontRef>
-        </p:style>
-        <p:txBody>
-          <a:bodyPr rtlCol="0" anchor="ctr"/>
-          <a:lstStyle/>
-          <a:p>
-            <a:pPr algn="ctr"/>
-          </a:p>
-        </p:txBody>
-      </p:sp>
-      <p:sp>
-        <p:nvSpPr>
-          <p:cNvPr id="15" name="Rectangle 14"/>
-          <p:cNvSpPr/>
-          <p:nvPr/>
-        </p:nvSpPr>
-        <p:spPr>
-          <a:xfrm>
-            <a:off x="868680" y="5257800"/>
-            <a:ext cx="162020" cy="201168"/>
-          </a:xfrm>
-          <a:prstGeom prst="rect">
-            <a:avLst/>
-          </a:prstGeom>
-          <a:solidFill>
-            <a:srgbClr val="F0DDC0"/>
-          </a:solidFill>
-          <a:ln>
-            <a:noFill/>
-          </a:ln>
-        </p:spPr>
-        <p:style>
-          <a:lnRef idx="1">
-            <a:schemeClr val="accent1"/>
-          </a:lnRef>
-          <a:fillRef idx="3">
-            <a:schemeClr val="accent1"/>
-          </a:fillRef>
-          <a:effectRef idx="2">
-            <a:schemeClr val="accent1"/>
-          </a:effectRef>
-          <a:fontRef idx="minor">
-            <a:schemeClr val="lt1"/>
-          </a:fontRef>
-        </p:style>
-        <p:txBody>
-          <a:bodyPr rtlCol="0" anchor="ctr"/>
-          <a:lstStyle/>
-          <a:p>
-            <a:pPr algn="ctr"/>
-          </a:p>
-        </p:txBody>
-      </p:sp>
-      <p:sp>
-        <p:nvSpPr>
-          <p:cNvPr id="16" name="Rectangle 15"/>
-          <p:cNvSpPr/>
-          <p:nvPr/>
-        </p:nvSpPr>
-        <p:spPr>
-          <a:xfrm>
-            <a:off x="1028700" y="5257800"/>
-            <a:ext cx="162020" cy="201168"/>
-          </a:xfrm>
-          <a:prstGeom prst="rect">
-            <a:avLst/>
-          </a:prstGeom>
-          <a:solidFill>
-            <a:srgbClr val="F0D9B4"/>
-          </a:solidFill>
-          <a:ln>
-            <a:noFill/>
-          </a:ln>
-        </p:spPr>
-        <p:style>
-          <a:lnRef idx="1">
-            <a:schemeClr val="accent1"/>
-          </a:lnRef>
-          <a:fillRef idx="3">
-            <a:schemeClr val="accent1"/>
-          </a:fillRef>
-          <a:effectRef idx="2">
-            <a:schemeClr val="accent1"/>
-          </a:effectRef>
-          <a:fontRef idx="minor">
-            <a:schemeClr val="lt1"/>
-          </a:fontRef>
-        </p:style>
-        <p:txBody>
-          <a:bodyPr rtlCol="0" anchor="ctr"/>
-          <a:lstStyle/>
-          <a:p>
-            <a:pPr algn="ctr"/>
-          </a:p>
-        </p:txBody>
-      </p:sp>
-      <p:sp>
-        <p:nvSpPr>
-          <p:cNvPr id="17" name="Rectangle 16"/>
-          <p:cNvSpPr/>
-          <p:nvPr/>
-        </p:nvSpPr>
-        <p:spPr>
-          <a:xfrm>
-            <a:off x="1188720" y="5257800"/>
-            <a:ext cx="162020" cy="201168"/>
-          </a:xfrm>
-          <a:prstGeom prst="rect">
-            <a:avLst/>
-          </a:prstGeom>
-          <a:solidFill>
-            <a:srgbClr val="F0D5A9"/>
-          </a:solidFill>
-          <a:ln>
-            <a:noFill/>
-          </a:ln>
-        </p:spPr>
-        <p:style>
-          <a:lnRef idx="1">
-            <a:schemeClr val="accent1"/>
-          </a:lnRef>
-          <a:fillRef idx="3">
-            <a:schemeClr val="accent1"/>
-          </a:fillRef>
-          <a:effectRef idx="2">
-            <a:schemeClr val="accent1"/>
-          </a:effectRef>
-          <a:fontRef idx="minor">
-            <a:schemeClr val="lt1"/>
-          </a:fontRef>
-        </p:style>
-        <p:txBody>
-          <a:bodyPr rtlCol="0" anchor="ctr"/>
-          <a:lstStyle/>
-          <a:p>
-            <a:pPr algn="ctr"/>
-          </a:p>
-        </p:txBody>
-      </p:sp>
-      <p:sp>
-        <p:nvSpPr>
-          <p:cNvPr id="18" name="Rectangle 17"/>
-          <p:cNvSpPr/>
-          <p:nvPr/>
-        </p:nvSpPr>
-        <p:spPr>
-          <a:xfrm>
-            <a:off x="1348740" y="5257800"/>
-            <a:ext cx="162020" cy="201168"/>
-          </a:xfrm>
-          <a:prstGeom prst="rect">
-            <a:avLst/>
-          </a:prstGeom>
-          <a:solidFill>
-            <a:srgbClr val="F1D09D"/>
-          </a:solidFill>
-          <a:ln>
-            <a:noFill/>
-          </a:ln>
-        </p:spPr>
-        <p:style>
-          <a:lnRef idx="1">
-            <a:schemeClr val="accent1"/>
-          </a:lnRef>
-          <a:fillRef idx="3">
-            <a:schemeClr val="accent1"/>
-          </a:fillRef>
-          <a:effectRef idx="2">
-            <a:schemeClr val="accent1"/>
-          </a:effectRef>
-          <a:fontRef idx="minor">
-            <a:schemeClr val="lt1"/>
-          </a:fontRef>
-        </p:style>
-        <p:txBody>
-          <a:bodyPr rtlCol="0" anchor="ctr"/>
-          <a:lstStyle/>
-          <a:p>
-            <a:pPr algn="ctr"/>
-          </a:p>
-        </p:txBody>
-      </p:sp>
-      <p:sp>
-        <p:nvSpPr>
-          <p:cNvPr id="19" name="Rectangle 18"/>
-          <p:cNvSpPr/>
-          <p:nvPr/>
-        </p:nvSpPr>
-        <p:spPr>
-          <a:xfrm>
-            <a:off x="1508760" y="5257800"/>
-            <a:ext cx="162020" cy="201168"/>
-          </a:xfrm>
-          <a:prstGeom prst="rect">
-            <a:avLst/>
-          </a:prstGeom>
-          <a:solidFill>
-            <a:srgbClr val="F1CC91"/>
-          </a:solidFill>
-          <a:ln>
-            <a:noFill/>
-          </a:ln>
-        </p:spPr>
-        <p:style>
-          <a:lnRef idx="1">
-            <a:schemeClr val="accent1"/>
-          </a:lnRef>
-          <a:fillRef idx="3">
-            <a:schemeClr val="accent1"/>
-          </a:fillRef>
-          <a:effectRef idx="2">
-            <a:schemeClr val="accent1"/>
-          </a:effectRef>
-          <a:fontRef idx="minor">
-            <a:schemeClr val="lt1"/>
-          </a:fontRef>
-        </p:style>
-        <p:txBody>
-          <a:bodyPr rtlCol="0" anchor="ctr"/>
-          <a:lstStyle/>
-          <a:p>
-            <a:pPr algn="ctr"/>
-          </a:p>
-        </p:txBody>
-      </p:sp>
-      <p:sp>
-        <p:nvSpPr>
-          <p:cNvPr id="20" name="Rectangle 19"/>
-          <p:cNvSpPr/>
-          <p:nvPr/>
-        </p:nvSpPr>
-        <p:spPr>
-          <a:xfrm>
-            <a:off x="1668780" y="5257800"/>
-            <a:ext cx="162020" cy="201168"/>
-          </a:xfrm>
-          <a:prstGeom prst="rect">
-            <a:avLst/>
-          </a:prstGeom>
-          <a:solidFill>
-            <a:srgbClr val="F1C886"/>
-          </a:solidFill>
-          <a:ln>
-            <a:noFill/>
-          </a:ln>
-        </p:spPr>
-        <p:style>
-          <a:lnRef idx="1">
-            <a:schemeClr val="accent1"/>
-          </a:lnRef>
-          <a:fillRef idx="3">
-            <a:schemeClr val="accent1"/>
-          </a:fillRef>
-          <a:effectRef idx="2">
-            <a:schemeClr val="accent1"/>
-          </a:effectRef>
-          <a:fontRef idx="minor">
-            <a:schemeClr val="lt1"/>
-          </a:fontRef>
-        </p:style>
-        <p:txBody>
-          <a:bodyPr rtlCol="0" anchor="ctr"/>
-          <a:lstStyle/>
-          <a:p>
-            <a:pPr algn="ctr"/>
-          </a:p>
-        </p:txBody>
-      </p:sp>
-      <p:sp>
-        <p:nvSpPr>
-          <p:cNvPr id="21" name="Rectangle 20"/>
-          <p:cNvSpPr/>
-          <p:nvPr/>
-        </p:nvSpPr>
-        <p:spPr>
-          <a:xfrm>
-            <a:off x="1828800" y="5257800"/>
-            <a:ext cx="162020" cy="201168"/>
-          </a:xfrm>
-          <a:prstGeom prst="rect">
-            <a:avLst/>
-          </a:prstGeom>
-          <a:solidFill>
-            <a:srgbClr val="F1C47A"/>
-          </a:solidFill>
-          <a:ln>
-            <a:noFill/>
-          </a:ln>
-        </p:spPr>
-        <p:style>
-          <a:lnRef idx="1">
-            <a:schemeClr val="accent1"/>
-          </a:lnRef>
-          <a:fillRef idx="3">
-            <a:schemeClr val="accent1"/>
-          </a:fillRef>
-          <a:effectRef idx="2">
-            <a:schemeClr val="accent1"/>
-          </a:effectRef>
-          <a:fontRef idx="minor">
-            <a:schemeClr val="lt1"/>
-          </a:fontRef>
-        </p:style>
-        <p:txBody>
-          <a:bodyPr rtlCol="0" anchor="ctr"/>
-          <a:lstStyle/>
-          <a:p>
-            <a:pPr algn="ctr"/>
-          </a:p>
-        </p:txBody>
-      </p:sp>
-      <p:sp>
-        <p:nvSpPr>
-          <p:cNvPr id="22" name="Rectangle 21"/>
-          <p:cNvSpPr/>
-          <p:nvPr/>
-        </p:nvSpPr>
-        <p:spPr>
-          <a:xfrm>
-            <a:off x="1988820" y="5257800"/>
-            <a:ext cx="162020" cy="201168"/>
-          </a:xfrm>
-          <a:prstGeom prst="rect">
-            <a:avLst/>
-          </a:prstGeom>
-          <a:solidFill>
-            <a:srgbClr val="F0BD74"/>
-          </a:solidFill>
-          <a:ln>
-            <a:noFill/>
-          </a:ln>
-        </p:spPr>
-        <p:style>
-          <a:lnRef idx="1">
-            <a:schemeClr val="accent1"/>
-          </a:lnRef>
-          <a:fillRef idx="3">
-            <a:schemeClr val="accent1"/>
-          </a:fillRef>
-          <a:effectRef idx="2">
-            <a:schemeClr val="accent1"/>
-          </a:effectRef>
-          <a:fontRef idx="minor">
-            <a:schemeClr val="lt1"/>
-          </a:fontRef>
-        </p:style>
-        <p:txBody>
-          <a:bodyPr rtlCol="0" anchor="ctr"/>
-          <a:lstStyle/>
-          <a:p>
-            <a:pPr algn="ctr"/>
-          </a:p>
-        </p:txBody>
-      </p:sp>
-      <p:sp>
-        <p:nvSpPr>
-          <p:cNvPr id="23" name="Rectangle 22"/>
-          <p:cNvSpPr/>
-          <p:nvPr/>
-        </p:nvSpPr>
-        <p:spPr>
-          <a:xfrm>
-            <a:off x="2148840" y="5257800"/>
-            <a:ext cx="162020" cy="201168"/>
-          </a:xfrm>
-          <a:prstGeom prst="rect">
-            <a:avLst/>
-          </a:prstGeom>
-          <a:solidFill>
-            <a:srgbClr val="EFB66E"/>
-          </a:solidFill>
-          <a:ln>
-            <a:noFill/>
-          </a:ln>
-        </p:spPr>
-        <p:style>
-          <a:lnRef idx="1">
-            <a:schemeClr val="accent1"/>
-          </a:lnRef>
-          <a:fillRef idx="3">
-            <a:schemeClr val="accent1"/>
-          </a:fillRef>
-          <a:effectRef idx="2">
-            <a:schemeClr val="accent1"/>
-          </a:effectRef>
-          <a:fontRef idx="minor">
-            <a:schemeClr val="lt1"/>
-          </a:fontRef>
-        </p:style>
-        <p:txBody>
-          <a:bodyPr rtlCol="0" anchor="ctr"/>
-          <a:lstStyle/>
-          <a:p>
-            <a:pPr algn="ctr"/>
-          </a:p>
-        </p:txBody>
-      </p:sp>
-      <p:sp>
-        <p:nvSpPr>
-          <p:cNvPr id="24" name="Rectangle 23"/>
-          <p:cNvSpPr/>
-          <p:nvPr/>
-        </p:nvSpPr>
-        <p:spPr>
-          <a:xfrm>
-            <a:off x="2308860" y="5257800"/>
-            <a:ext cx="162020" cy="201168"/>
-          </a:xfrm>
-          <a:prstGeom prst="rect">
-            <a:avLst/>
-          </a:prstGeom>
-          <a:solidFill>
-            <a:srgbClr val="EEAF68"/>
-          </a:solidFill>
-          <a:ln>
-            <a:noFill/>
-          </a:ln>
-        </p:spPr>
-        <p:style>
-          <a:lnRef idx="1">
-            <a:schemeClr val="accent1"/>
-          </a:lnRef>
-          <a:fillRef idx="3">
-            <a:schemeClr val="accent1"/>
-          </a:fillRef>
-          <a:effectRef idx="2">
-            <a:schemeClr val="accent1"/>
-          </a:effectRef>
-          <a:fontRef idx="minor">
-            <a:schemeClr val="lt1"/>
-          </a:fontRef>
-        </p:style>
-        <p:txBody>
-          <a:bodyPr rtlCol="0" anchor="ctr"/>
-          <a:lstStyle/>
-          <a:p>
-            <a:pPr algn="ctr"/>
-          </a:p>
-        </p:txBody>
-      </p:sp>
-      <p:sp>
-        <p:nvSpPr>
-          <p:cNvPr id="25" name="Rectangle 24"/>
-          <p:cNvSpPr/>
-          <p:nvPr/>
-        </p:nvSpPr>
-        <p:spPr>
-          <a:xfrm>
-            <a:off x="2468880" y="5257800"/>
-            <a:ext cx="162020" cy="201168"/>
-          </a:xfrm>
-          <a:prstGeom prst="rect">
-            <a:avLst/>
-          </a:prstGeom>
-          <a:solidFill>
-            <a:srgbClr val="EDA862"/>
-          </a:solidFill>
-          <a:ln>
-            <a:noFill/>
-          </a:ln>
-        </p:spPr>
-        <p:style>
-          <a:lnRef idx="1">
-            <a:schemeClr val="accent1"/>
-          </a:lnRef>
-          <a:fillRef idx="3">
-            <a:schemeClr val="accent1"/>
-          </a:fillRef>
-          <a:effectRef idx="2">
-            <a:schemeClr val="accent1"/>
-          </a:effectRef>
-          <a:fontRef idx="minor">
-            <a:schemeClr val="lt1"/>
-          </a:fontRef>
-        </p:style>
-        <p:txBody>
-          <a:bodyPr rtlCol="0" anchor="ctr"/>
-          <a:lstStyle/>
-          <a:p>
-            <a:pPr algn="ctr"/>
-          </a:p>
-        </p:txBody>
-      </p:sp>
-      <p:sp>
-        <p:nvSpPr>
-          <p:cNvPr id="26" name="Rectangle 25"/>
-          <p:cNvSpPr/>
-          <p:nvPr/>
-        </p:nvSpPr>
-        <p:spPr>
-          <a:xfrm>
-            <a:off x="2628900" y="5257800"/>
-            <a:ext cx="162020" cy="201168"/>
-          </a:xfrm>
-          <a:prstGeom prst="rect">
-            <a:avLst/>
-          </a:prstGeom>
-          <a:solidFill>
-            <a:srgbClr val="EBA05C"/>
-          </a:solidFill>
-          <a:ln>
-            <a:noFill/>
-          </a:ln>
-        </p:spPr>
-        <p:style>
-          <a:lnRef idx="1">
-            <a:schemeClr val="accent1"/>
-          </a:lnRef>
-          <a:fillRef idx="3">
-            <a:schemeClr val="accent1"/>
-          </a:fillRef>
-          <a:effectRef idx="2">
-            <a:schemeClr val="accent1"/>
-          </a:effectRef>
-          <a:fontRef idx="minor">
-            <a:schemeClr val="lt1"/>
-          </a:fontRef>
-        </p:style>
-        <p:txBody>
-          <a:bodyPr rtlCol="0" anchor="ctr"/>
-          <a:lstStyle/>
-          <a:p>
-            <a:pPr algn="ctr"/>
-          </a:p>
-        </p:txBody>
-      </p:sp>
-      <p:sp>
-        <p:nvSpPr>
-          <p:cNvPr id="27" name="Rectangle 26"/>
-          <p:cNvSpPr/>
-          <p:nvPr/>
-        </p:nvSpPr>
-        <p:spPr>
-          <a:xfrm>
-            <a:off x="2788920" y="5257800"/>
-            <a:ext cx="162020" cy="201168"/>
-          </a:xfrm>
-          <a:prstGeom prst="rect">
-            <a:avLst/>
-          </a:prstGeom>
-          <a:solidFill>
-            <a:srgbClr val="EA9956"/>
-          </a:solidFill>
-          <a:ln>
-            <a:noFill/>
-          </a:ln>
-        </p:spPr>
-        <p:style>
-          <a:lnRef idx="1">
-            <a:schemeClr val="accent1"/>
-          </a:lnRef>
-          <a:fillRef idx="3">
-            <a:schemeClr val="accent1"/>
-          </a:fillRef>
-          <a:effectRef idx="2">
-            <a:schemeClr val="accent1"/>
-          </a:effectRef>
-          <a:fontRef idx="minor">
-            <a:schemeClr val="lt1"/>
-          </a:fontRef>
-        </p:style>
-        <p:txBody>
-          <a:bodyPr rtlCol="0" anchor="ctr"/>
-          <a:lstStyle/>
-          <a:p>
-            <a:pPr algn="ctr"/>
-          </a:p>
-        </p:txBody>
-      </p:sp>
-      <p:sp>
-        <p:nvSpPr>
-          <p:cNvPr id="28" name="Rectangle 27"/>
-          <p:cNvSpPr/>
-          <p:nvPr/>
-        </p:nvSpPr>
-        <p:spPr>
-          <a:xfrm>
-            <a:off x="2948940" y="5257800"/>
-            <a:ext cx="162020" cy="201168"/>
-          </a:xfrm>
-          <a:prstGeom prst="rect">
-            <a:avLst/>
-          </a:prstGeom>
-          <a:solidFill>
-            <a:srgbClr val="E99250"/>
-          </a:solidFill>
-          <a:ln>
-            <a:noFill/>
-          </a:ln>
-        </p:spPr>
-        <p:style>
-          <a:lnRef idx="1">
-            <a:schemeClr val="accent1"/>
-          </a:lnRef>
-          <a:fillRef idx="3">
-            <a:schemeClr val="accent1"/>
-          </a:fillRef>
-          <a:effectRef idx="2">
-            <a:schemeClr val="accent1"/>
-          </a:effectRef>
-          <a:fontRef idx="minor">
-            <a:schemeClr val="lt1"/>
-          </a:fontRef>
-        </p:style>
-        <p:txBody>
-          <a:bodyPr rtlCol="0" anchor="ctr"/>
-          <a:lstStyle/>
-          <a:p>
-            <a:pPr algn="ctr"/>
-          </a:p>
-        </p:txBody>
-      </p:sp>
-      <p:sp>
-        <p:nvSpPr>
-          <p:cNvPr id="29" name="Rectangle 28"/>
-          <p:cNvSpPr/>
-          <p:nvPr/>
-        </p:nvSpPr>
-        <p:spPr>
-          <a:xfrm>
-            <a:off x="3108960" y="5257800"/>
-            <a:ext cx="162020" cy="201168"/>
-          </a:xfrm>
-          <a:prstGeom prst="rect">
-            <a:avLst/>
-          </a:prstGeom>
-          <a:solidFill>
-            <a:srgbClr val="E88B4A"/>
-          </a:solidFill>
-          <a:ln>
-            <a:noFill/>
-          </a:ln>
-        </p:spPr>
-        <p:style>
-          <a:lnRef idx="1">
-            <a:schemeClr val="accent1"/>
-          </a:lnRef>
-          <a:fillRef idx="3">
-            <a:schemeClr val="accent1"/>
-          </a:fillRef>
-          <a:effectRef idx="2">
-            <a:schemeClr val="accent1"/>
-          </a:effectRef>
-          <a:fontRef idx="minor">
-            <a:schemeClr val="lt1"/>
-          </a:fontRef>
-        </p:style>
-        <p:txBody>
-          <a:bodyPr rtlCol="0" anchor="ctr"/>
-          <a:lstStyle/>
-          <a:p>
-            <a:pPr algn="ctr"/>
-          </a:p>
-        </p:txBody>
-      </p:sp>
-      <p:sp>
-        <p:nvSpPr>
-          <p:cNvPr id="30" name="Rectangle 29"/>
-          <p:cNvSpPr/>
-          <p:nvPr/>
-        </p:nvSpPr>
-        <p:spPr>
-          <a:xfrm>
-            <a:off x="3268980" y="5257800"/>
-            <a:ext cx="162020" cy="201168"/>
-          </a:xfrm>
-          <a:prstGeom prst="rect">
-            <a:avLst/>
-          </a:prstGeom>
-          <a:solidFill>
-            <a:srgbClr val="E38146"/>
-          </a:solidFill>
-          <a:ln>
-            <a:noFill/>
-          </a:ln>
-        </p:spPr>
-        <p:style>
-          <a:lnRef idx="1">
-            <a:schemeClr val="accent1"/>
-          </a:lnRef>
-          <a:fillRef idx="3">
-            <a:schemeClr val="accent1"/>
-          </a:fillRef>
-          <a:effectRef idx="2">
-            <a:schemeClr val="accent1"/>
-          </a:effectRef>
-          <a:fontRef idx="minor">
-            <a:schemeClr val="lt1"/>
-          </a:fontRef>
-        </p:style>
-        <p:txBody>
-          <a:bodyPr rtlCol="0" anchor="ctr"/>
-          <a:lstStyle/>
-          <a:p>
-            <a:pPr algn="ctr"/>
-          </a:p>
-        </p:txBody>
-      </p:sp>
-      <p:sp>
-        <p:nvSpPr>
-          <p:cNvPr id="31" name="Rectangle 30"/>
-          <p:cNvSpPr/>
-          <p:nvPr/>
-        </p:nvSpPr>
-        <p:spPr>
-          <a:xfrm>
-            <a:off x="3429000" y="5257800"/>
-            <a:ext cx="162020" cy="201168"/>
-          </a:xfrm>
-          <a:prstGeom prst="rect">
-            <a:avLst/>
-          </a:prstGeom>
-          <a:solidFill>
-            <a:srgbClr val="DE7742"/>
-          </a:solidFill>
-          <a:ln>
-            <a:noFill/>
-          </a:ln>
-        </p:spPr>
-        <p:style>
-          <a:lnRef idx="1">
-            <a:schemeClr val="accent1"/>
-          </a:lnRef>
-          <a:fillRef idx="3">
-            <a:schemeClr val="accent1"/>
-          </a:fillRef>
-          <a:effectRef idx="2">
-            <a:schemeClr val="accent1"/>
-          </a:effectRef>
-          <a:fontRef idx="minor">
-            <a:schemeClr val="lt1"/>
-          </a:fontRef>
-        </p:style>
-        <p:txBody>
-          <a:bodyPr rtlCol="0" anchor="ctr"/>
-          <a:lstStyle/>
-          <a:p>
-            <a:pPr algn="ctr"/>
-          </a:p>
-        </p:txBody>
-      </p:sp>
-      <p:sp>
-        <p:nvSpPr>
-          <p:cNvPr id="32" name="Rectangle 31"/>
-          <p:cNvSpPr/>
-          <p:nvPr/>
-        </p:nvSpPr>
-        <p:spPr>
-          <a:xfrm>
-            <a:off x="3589020" y="5257800"/>
-            <a:ext cx="162020" cy="201168"/>
-          </a:xfrm>
-          <a:prstGeom prst="rect">
-            <a:avLst/>
-          </a:prstGeom>
-          <a:solidFill>
-            <a:srgbClr val="D86D3D"/>
-          </a:solidFill>
-          <a:ln>
-            <a:noFill/>
-          </a:ln>
-        </p:spPr>
-        <p:style>
-          <a:lnRef idx="1">
-            <a:schemeClr val="accent1"/>
-          </a:lnRef>
-          <a:fillRef idx="3">
-            <a:schemeClr val="accent1"/>
-          </a:fillRef>
-          <a:effectRef idx="2">
-            <a:schemeClr val="accent1"/>
-          </a:effectRef>
-          <a:fontRef idx="minor">
-            <a:schemeClr val="lt1"/>
-          </a:fontRef>
-        </p:style>
-        <p:txBody>
-          <a:bodyPr rtlCol="0" anchor="ctr"/>
-          <a:lstStyle/>
-          <a:p>
-            <a:pPr algn="ctr"/>
-          </a:p>
-        </p:txBody>
-      </p:sp>
-      <p:sp>
-        <p:nvSpPr>
-          <p:cNvPr id="33" name="Rectangle 32"/>
-          <p:cNvSpPr/>
-          <p:nvPr/>
-        </p:nvSpPr>
-        <p:spPr>
-          <a:xfrm>
-            <a:off x="3749040" y="5257800"/>
-            <a:ext cx="162020" cy="201168"/>
-          </a:xfrm>
-          <a:prstGeom prst="rect">
-            <a:avLst/>
-          </a:prstGeom>
-          <a:solidFill>
-            <a:srgbClr val="D36339"/>
-          </a:solidFill>
-          <a:ln>
-            <a:noFill/>
-          </a:ln>
-        </p:spPr>
-        <p:style>
-          <a:lnRef idx="1">
-            <a:schemeClr val="accent1"/>
-          </a:lnRef>
-          <a:fillRef idx="3">
-            <a:schemeClr val="accent1"/>
-          </a:fillRef>
-          <a:effectRef idx="2">
-            <a:schemeClr val="accent1"/>
-          </a:effectRef>
-          <a:fontRef idx="minor">
-            <a:schemeClr val="lt1"/>
-          </a:fontRef>
-        </p:style>
-        <p:txBody>
-          <a:bodyPr rtlCol="0" anchor="ctr"/>
-          <a:lstStyle/>
-          <a:p>
-            <a:pPr algn="ctr"/>
-          </a:p>
-        </p:txBody>
-      </p:sp>
-      <p:sp>
-        <p:nvSpPr>
-          <p:cNvPr id="34" name="Rectangle 33"/>
-          <p:cNvSpPr/>
-          <p:nvPr/>
-        </p:nvSpPr>
-        <p:spPr>
-          <a:xfrm>
-            <a:off x="3909060" y="5257800"/>
-            <a:ext cx="162020" cy="201168"/>
-          </a:xfrm>
-          <a:prstGeom prst="rect">
-            <a:avLst/>
-          </a:prstGeom>
-          <a:solidFill>
-            <a:srgbClr val="CE5935"/>
-          </a:solidFill>
-          <a:ln>
-            <a:noFill/>
-          </a:ln>
-        </p:spPr>
-        <p:style>
-          <a:lnRef idx="1">
-            <a:schemeClr val="accent1"/>
-          </a:lnRef>
-          <a:fillRef idx="3">
-            <a:schemeClr val="accent1"/>
-          </a:fillRef>
-          <a:effectRef idx="2">
-            <a:schemeClr val="accent1"/>
-          </a:effectRef>
-          <a:fontRef idx="minor">
-            <a:schemeClr val="lt1"/>
-          </a:fontRef>
-        </p:style>
-        <p:txBody>
-          <a:bodyPr rtlCol="0" anchor="ctr"/>
-          <a:lstStyle/>
-          <a:p>
-            <a:pPr algn="ctr"/>
-          </a:p>
-        </p:txBody>
-      </p:sp>
-      <p:sp>
-        <p:nvSpPr>
-          <p:cNvPr id="35" name="Rectangle 34"/>
-          <p:cNvSpPr/>
-          <p:nvPr/>
-        </p:nvSpPr>
-        <p:spPr>
-          <a:xfrm>
-            <a:off x="4069080" y="5257800"/>
-            <a:ext cx="162020" cy="201168"/>
-          </a:xfrm>
-          <a:prstGeom prst="rect">
-            <a:avLst/>
-          </a:prstGeom>
-          <a:solidFill>
-            <a:srgbClr val="C94F31"/>
-          </a:solidFill>
-          <a:ln>
-            <a:noFill/>
-          </a:ln>
-        </p:spPr>
-        <p:style>
-          <a:lnRef idx="1">
-            <a:schemeClr val="accent1"/>
-          </a:lnRef>
-          <a:fillRef idx="3">
-            <a:schemeClr val="accent1"/>
-          </a:fillRef>
-          <a:effectRef idx="2">
-            <a:schemeClr val="accent1"/>
-          </a:effectRef>
-          <a:fontRef idx="minor">
-            <a:schemeClr val="lt1"/>
-          </a:fontRef>
-        </p:style>
-        <p:txBody>
-          <a:bodyPr rtlCol="0" anchor="ctr"/>
-          <a:lstStyle/>
-          <a:p>
-            <a:pPr algn="ctr"/>
-          </a:p>
-        </p:txBody>
-      </p:sp>
-      <p:sp>
-        <p:nvSpPr>
-          <p:cNvPr id="36" name="Rectangle 35"/>
-          <p:cNvSpPr/>
-          <p:nvPr/>
-        </p:nvSpPr>
-        <p:spPr>
-          <a:xfrm>
-            <a:off x="4229100" y="5257800"/>
-            <a:ext cx="162020" cy="201168"/>
-          </a:xfrm>
-          <a:prstGeom prst="rect">
-            <a:avLst/>
-          </a:prstGeom>
-          <a:solidFill>
-            <a:srgbClr val="C4452D"/>
-          </a:solidFill>
-          <a:ln>
-            <a:noFill/>
-          </a:ln>
-        </p:spPr>
-        <p:style>
-          <a:lnRef idx="1">
-            <a:schemeClr val="accent1"/>
-          </a:lnRef>
-          <a:fillRef idx="3">
-            <a:schemeClr val="accent1"/>
-          </a:fillRef>
-          <a:effectRef idx="2">
-            <a:schemeClr val="accent1"/>
-          </a:effectRef>
-          <a:fontRef idx="minor">
-            <a:schemeClr val="lt1"/>
-          </a:fontRef>
-        </p:style>
-        <p:txBody>
-          <a:bodyPr rtlCol="0" anchor="ctr"/>
-          <a:lstStyle/>
-          <a:p>
-            <a:pPr algn="ctr"/>
-          </a:p>
-        </p:txBody>
-      </p:sp>
-      <p:sp>
-        <p:nvSpPr>
-          <p:cNvPr id="37" name="TextBox 36"/>
-          <p:cNvSpPr txBox="1"/>
-          <p:nvPr/>
-        </p:nvSpPr>
-        <p:spPr>
-          <a:xfrm>
-            <a:off x="548640" y="5532120"/>
-            <a:ext cx="1371600" cy="256032"/>
+            <a:off x="502920" y="5623560"/>
+            <a:ext cx="11155680" cy="256032"/>
           </a:xfrm>
           <a:prstGeom prst="rect">
             <a:avLst/>
@@ -4813,64 +3781,28 @@
           </a:bodyPr>
           <a:lstStyle/>
           <a:p>
-            <a:pPr algn="l"/>
-            <a:r>
-              <a:rPr sz="1000" b="0">
+            <a:r>
+              <a:rPr sz="1100" b="0">
                 <a:solidFill>
                   <a:srgbClr val="5C554C"/>
                 </a:solidFill>
                 <a:latin typeface="Calibri"/>
               </a:rPr>
-              <a:t>Lower volume</a:t>
-            </a:r>
-          </a:p>
-        </p:txBody>
-      </p:sp>
-      <p:sp>
-        <p:nvSpPr>
-          <p:cNvPr id="38" name="TextBox 37"/>
+              <a:t>Area is linear with volume (Documentation ≈ 1500× Feedback). Discord is unmeasured — not on the size scale.</a:t>
+            </a:r>
+          </a:p>
+        </p:txBody>
+      </p:sp>
+      <p:sp>
+        <p:nvSpPr>
+          <p:cNvPr id="14" name="TextBox 13"/>
           <p:cNvSpPr txBox="1"/>
           <p:nvPr/>
         </p:nvSpPr>
         <p:spPr>
           <a:xfrm>
-            <a:off x="3017520" y="5532120"/>
-            <a:ext cx="1371600" cy="256032"/>
-          </a:xfrm>
-          <a:prstGeom prst="rect">
-            <a:avLst/>
-          </a:prstGeom>
-          <a:noFill/>
-        </p:spPr>
-        <p:txBody>
-          <a:bodyPr wrap="none">
-            <a:spAutoFit/>
-          </a:bodyPr>
-          <a:lstStyle/>
-          <a:p>
-            <a:pPr algn="r"/>
-            <a:r>
-              <a:rPr sz="1000" b="0">
-                <a:solidFill>
-                  <a:srgbClr val="5C554C"/>
-                </a:solidFill>
-                <a:latin typeface="Calibri"/>
-              </a:rPr>
-              <a:t>Higher volume</a:t>
-            </a:r>
-          </a:p>
-        </p:txBody>
-      </p:sp>
-      <p:sp>
-        <p:nvSpPr>
-          <p:cNvPr id="39" name="TextBox 38"/>
-          <p:cNvSpPr txBox="1"/>
-          <p:nvPr/>
-        </p:nvSpPr>
-        <p:spPr>
-          <a:xfrm>
-            <a:off x="548640" y="5989320"/>
-            <a:ext cx="11064240" cy="411480"/>
+            <a:off x="502920" y="5989320"/>
+            <a:ext cx="11155680" cy="365760"/>
           </a:xfrm>
           <a:prstGeom prst="rect">
             <a:avLst/>

</xml_diff>